<commit_message>
Complete Smart RAG V2 improvements, validation and documentation
</commit_message>
<xml_diff>
--- a/Presentation/Smart_RAG_Final_Presentation_Updated.pptx
+++ b/Presentation/Smart_RAG_Final_Presentation_Updated.pptx
@@ -19,6 +19,7 @@
     <p:sldId id="267" r:id="rId18"/>
     <p:sldId id="268" r:id="rId19"/>
     <p:sldId id="269" r:id="rId20"/>
+    <p:sldId id="270" r:id="rId21"/>
   </p:sldIdLst>
   <p:sldSz cx="12191695" cy="6858000" type="screen4x3"/>
   <p:notesSz cx="6858000" cy="9144000"/>
@@ -4033,7 +4034,7 @@
               </a:defRPr>
             </a:pPr>
             <a:r>
-              <a:t>219 core automated tests passed in the verified baseline</a:t>
+              <a:t>Latest full pytest run: 333 / 333 tests passed</a:t>
             </a:r>
           </a:p>
         </p:txBody>
@@ -4085,7 +4086,7 @@
               </a:defRPr>
             </a:pPr>
             <a:r>
-              <a:t>Seven tests in two experimental modality modules remain failing</a:t>
+              <a:t>No failures in the latest complete automated test run</a:t>
             </a:r>
           </a:p>
         </p:txBody>
@@ -4866,7 +4867,7 @@
               </a:defRPr>
             </a:pPr>
             <a:r>
-              <a:t>Pending before final submission: local code ZIP refresh and repository upload</a:t>
+              <a:t>Final ZIP packaging and submission verification required</a:t>
             </a:r>
           </a:p>
         </p:txBody>
@@ -5093,6 +5094,91 @@
 </p:sld>
 </file>
 
+<file path=ppt/slides/slide15.xml><?xml version="1.0" encoding="utf-8"?>
+<p:sld xmlns:a="http://schemas.openxmlformats.org/drawingml/2006/main" xmlns:p="http://schemas.openxmlformats.org/presentationml/2006/main" xmlns:r="http://schemas.openxmlformats.org/officeDocument/2006/relationships">
+  <p:cSld>
+    <p:spTree>
+      <p:nvGrpSpPr>
+        <p:cNvPr id="1" name=""/>
+        <p:cNvGrpSpPr/>
+        <p:nvPr/>
+      </p:nvGrpSpPr>
+      <p:grpSpPr/>
+      <p:sp>
+        <p:nvSpPr>
+          <p:cNvPr id="2" name="Title 1"/>
+          <p:cNvSpPr>
+            <a:spLocks noGrp="1"/>
+          </p:cNvSpPr>
+          <p:nvPr>
+            <p:ph type="title"/>
+          </p:nvPr>
+        </p:nvSpPr>
+        <p:spPr/>
+        <p:txBody>
+          <a:bodyPr/>
+          <a:lstStyle/>
+          <a:p>
+            <a:r>
+              <a:t>V2 Final Verification</a:t>
+            </a:r>
+          </a:p>
+        </p:txBody>
+      </p:sp>
+      <p:sp>
+        <p:nvSpPr>
+          <p:cNvPr id="3" name="Content Placeholder 2"/>
+          <p:cNvSpPr>
+            <a:spLocks noGrp="1"/>
+          </p:cNvSpPr>
+          <p:nvPr>
+            <p:ph idx="1"/>
+          </p:nvPr>
+        </p:nvSpPr>
+        <p:spPr/>
+        <p:txBody>
+          <a:bodyPr/>
+          <a:lstStyle/>
+          <a:p>
+            <a:r>
+              <a:t>21 October 2026</a:t>
+            </a:r>
+          </a:p>
+          <a:p>
+            <a:r>
+              <a:t>Generation model: qwen2.5:7b</a:t>
+            </a:r>
+          </a:p>
+          <a:p>
+            <a:r>
+              <a:t>Citation and relevance validation: qwen2.5:3b</a:t>
+            </a:r>
+          </a:p>
+          <a:p>
+            <a:r>
+              <a:t>Automated tests: 333 / 333 passed</a:t>
+            </a:r>
+          </a:p>
+          <a:p>
+            <a:r>
+              <a:t>Live negation test: HTTP 200, answered, two accepted cited facts</a:t>
+            </a:r>
+          </a:p>
+          <a:p>
+            <a:r>
+              <a:t>Historical 20-question accuracy: 50% (12 October 2026; not rerun for V2)</a:t>
+            </a:r>
+          </a:p>
+        </p:txBody>
+      </p:sp>
+    </p:spTree>
+  </p:cSld>
+  <p:clrMapOvr>
+    <a:masterClrMapping/>
+  </p:clrMapOvr>
+</p:sld>
+</file>
+
 <file path=ppt/slides/slide2.xml><?xml version="1.0" encoding="utf-8"?>
 <p:sld xmlns:a="http://schemas.openxmlformats.org/drawingml/2006/main" xmlns:p="http://schemas.openxmlformats.org/presentationml/2006/main" xmlns:r="http://schemas.openxmlformats.org/officeDocument/2006/relationships">
   <p:cSld>
@@ -7041,7 +7127,7 @@
               </a:defRPr>
             </a:pPr>
             <a:r>
-              <a:t>Local generation model: qwen2.5:3b via Ollama</a:t>
+              <a:t>Generation: qwen2.5:7b; validation: qwen2.5:3b via Ollama</a:t>
             </a:r>
           </a:p>
         </p:txBody>

</xml_diff>